<commit_message>
Cambio en presentacion pptx
</commit_message>
<xml_diff>
--- a/Clase 1/Teoria/Clase 1 - Presentación.pptx
+++ b/Clase 1/Teoria/Clase 1 - Presentación.pptx
@@ -28,30 +28,27 @@
     <p:embeddedFont>
       <p:font typeface="EB Garamond" panose="00000500000000000000" pitchFamily="2" charset="0"/>
       <p:regular r:id="rId16"/>
-      <p:bold r:id="rId17"/>
-      <p:italic r:id="rId18"/>
-      <p:boldItalic r:id="rId19"/>
     </p:embeddedFont>
     <p:embeddedFont>
       <p:font typeface="Kantumruy Pro" panose="020B0604020202020204" charset="0"/>
-      <p:regular r:id="rId20"/>
-      <p:bold r:id="rId21"/>
-      <p:italic r:id="rId22"/>
-      <p:boldItalic r:id="rId23"/>
+      <p:regular r:id="rId17"/>
+      <p:bold r:id="rId18"/>
+      <p:italic r:id="rId19"/>
+      <p:boldItalic r:id="rId20"/>
     </p:embeddedFont>
     <p:embeddedFont>
       <p:font typeface="Kantumruy Pro Medium" panose="020B0604020202020204" charset="0"/>
-      <p:regular r:id="rId24"/>
-      <p:bold r:id="rId25"/>
-      <p:italic r:id="rId26"/>
-      <p:boldItalic r:id="rId27"/>
+      <p:regular r:id="rId21"/>
+      <p:bold r:id="rId22"/>
+      <p:italic r:id="rId23"/>
+      <p:boldItalic r:id="rId24"/>
     </p:embeddedFont>
     <p:embeddedFont>
       <p:font typeface="Kantumruy Pro SemiBold" panose="020B0604020202020204" charset="0"/>
-      <p:regular r:id="rId28"/>
-      <p:bold r:id="rId29"/>
-      <p:italic r:id="rId30"/>
-      <p:boldItalic r:id="rId31"/>
+      <p:regular r:id="rId25"/>
+      <p:bold r:id="rId26"/>
+      <p:italic r:id="rId27"/>
+      <p:boldItalic r:id="rId28"/>
     </p:embeddedFont>
   </p:embeddedFontLst>
   <p:defaultTextStyle>
@@ -299,7 +296,7 @@
       </p15:sldGuideLst>
     </p:ext>
     <p:ext uri="GoogleSlidesCustomDataVersion2">
-      <go:slidesCustomData xmlns:go="http://customooxmlschemas.google.com/" xmlns:ahyp="http://schemas.microsoft.com/office/drawing/2018/hyperlinkcolor" xmlns:p15="http://schemas.microsoft.com/office/powerpoint/2012/main" xmlns:p14="http://schemas.microsoft.com/office/powerpoint/2010/main" xmlns:com="http://schemas.openxmlformats.org/drawingml/2006/compatibility" xmlns:pvml="urn:schemas-microsoft-com:office:powerpoint" xmlns:v="urn:schemas-microsoft-com:vml" xmlns:o="urn:schemas-microsoft-com:office:office" xmlns:dgm="http://schemas.openxmlformats.org/drawingml/2006/diagram" xmlns:c="http://schemas.openxmlformats.org/drawingml/2006/chart" xmlns:mv="urn:schemas-microsoft-com:mac:vml" xmlns:mc="http://schemas.openxmlformats.org/markup-compatibility/2006" xmlns="" r:id="rId82" roundtripDataSignature="AMtx7mjSVOdFovUJ0JlZi30yN+jqAb7pvQ=="/>
+      <go:slidesCustomData xmlns="" xmlns:mc="http://schemas.openxmlformats.org/markup-compatibility/2006" xmlns:mv="urn:schemas-microsoft-com:mac:vml" xmlns:c="http://schemas.openxmlformats.org/drawingml/2006/chart" xmlns:dgm="http://schemas.openxmlformats.org/drawingml/2006/diagram" xmlns:o="urn:schemas-microsoft-com:office:office" xmlns:v="urn:schemas-microsoft-com:vml" xmlns:pvml="urn:schemas-microsoft-com:office:powerpoint" xmlns:com="http://schemas.openxmlformats.org/drawingml/2006/compatibility" xmlns:p14="http://schemas.microsoft.com/office/powerpoint/2010/main" xmlns:p15="http://schemas.microsoft.com/office/powerpoint/2012/main" xmlns:ahyp="http://schemas.microsoft.com/office/drawing/2018/hyperlinkcolor" xmlns:go="http://customooxmlschemas.google.com/" r:id="rId82" roundtripDataSignature="AMtx7mjSVOdFovUJ0JlZi30yN+jqAb7pvQ=="/>
     </p:ext>
   </p:extLst>
 </p:presentation>
@@ -51897,7 +51894,7 @@
         <p:spPr>
           <a:xfrm>
             <a:off x="404622" y="1273394"/>
-            <a:ext cx="11632172" cy="4199611"/>
+            <a:ext cx="11632172" cy="3276282"/>
           </a:xfrm>
           <a:prstGeom prst="rect">
             <a:avLst/>
@@ -52064,167 +52061,7 @@
                 <a:effectLst/>
                 <a:latin typeface="Avenir"/>
               </a:rPr>
-              <a:t>Python para el análisis de datos: Archivos de entrada/salida. Cómputo de estadísticos. Regresión lineal.</a:t>
-            </a:r>
-          </a:p>
-          <a:p>
-            <a:pPr>
-              <a:lnSpc>
-                <a:spcPct val="150000"/>
-              </a:lnSpc>
-              <a:buNone/>
-            </a:pPr>
-            <a:r>
-              <a:rPr lang="es-AR" sz="2000" b="0" i="0" dirty="0">
-                <a:solidFill>
-                  <a:schemeClr val="accent6">
-                    <a:lumMod val="75000"/>
-                  </a:schemeClr>
-                </a:solidFill>
-                <a:effectLst/>
-                <a:latin typeface="Avenir"/>
-              </a:rPr>
-              <a:t>● </a:t>
-            </a:r>
-            <a:r>
-              <a:rPr lang="es-AR" sz="2000" b="1" i="0" dirty="0">
-                <a:solidFill>
-                  <a:schemeClr val="accent6">
-                    <a:lumMod val="75000"/>
-                  </a:schemeClr>
-                </a:solidFill>
-                <a:effectLst/>
-                <a:latin typeface="Avenir"/>
-              </a:rPr>
-              <a:t>Visualización de datos. Aplicaciones con </a:t>
-            </a:r>
-            <a:r>
-              <a:rPr lang="es-AR" sz="2000" b="1" i="0" dirty="0" err="1">
-                <a:solidFill>
-                  <a:schemeClr val="accent6">
-                    <a:lumMod val="75000"/>
-                  </a:schemeClr>
-                </a:solidFill>
-                <a:effectLst/>
-                <a:latin typeface="Avenir"/>
-              </a:rPr>
-              <a:t>Numpy</a:t>
-            </a:r>
-            <a:r>
-              <a:rPr lang="es-AR" sz="2000" b="1" i="0" dirty="0">
-                <a:solidFill>
-                  <a:schemeClr val="accent6">
-                    <a:lumMod val="75000"/>
-                  </a:schemeClr>
-                </a:solidFill>
-                <a:effectLst/>
-                <a:latin typeface="Avenir"/>
-              </a:rPr>
-              <a:t>, </a:t>
-            </a:r>
-            <a:r>
-              <a:rPr lang="es-AR" sz="2000" b="1" i="0" dirty="0" err="1">
-                <a:solidFill>
-                  <a:schemeClr val="accent6">
-                    <a:lumMod val="75000"/>
-                  </a:schemeClr>
-                </a:solidFill>
-                <a:effectLst/>
-                <a:latin typeface="Avenir"/>
-              </a:rPr>
-              <a:t>SciPy</a:t>
-            </a:r>
-            <a:r>
-              <a:rPr lang="es-AR" sz="2000" b="1" i="0" dirty="0">
-                <a:solidFill>
-                  <a:schemeClr val="accent6">
-                    <a:lumMod val="75000"/>
-                  </a:schemeClr>
-                </a:solidFill>
-                <a:effectLst/>
-                <a:latin typeface="Avenir"/>
-              </a:rPr>
-              <a:t> y </a:t>
-            </a:r>
-            <a:r>
-              <a:rPr lang="es-AR" sz="2000" b="1" i="0" dirty="0" err="1">
-                <a:solidFill>
-                  <a:schemeClr val="accent6">
-                    <a:lumMod val="75000"/>
-                  </a:schemeClr>
-                </a:solidFill>
-                <a:effectLst/>
-                <a:latin typeface="Avenir"/>
-              </a:rPr>
-              <a:t>Matplotlib</a:t>
-            </a:r>
-            <a:r>
-              <a:rPr lang="es-AR" sz="2000" b="1" i="0" dirty="0">
-                <a:solidFill>
-                  <a:schemeClr val="accent6">
-                    <a:lumMod val="75000"/>
-                  </a:schemeClr>
-                </a:solidFill>
-                <a:effectLst/>
-                <a:latin typeface="Avenir"/>
-              </a:rPr>
-              <a:t>.</a:t>
-            </a:r>
-          </a:p>
-          <a:p>
-            <a:pPr>
-              <a:lnSpc>
-                <a:spcPct val="150000"/>
-              </a:lnSpc>
-              <a:buNone/>
-            </a:pPr>
-            <a:r>
-              <a:rPr lang="es-AR" sz="2000" b="0" i="0" dirty="0">
-                <a:solidFill>
-                  <a:schemeClr val="accent6">
-                    <a:lumMod val="75000"/>
-                  </a:schemeClr>
-                </a:solidFill>
-                <a:effectLst/>
-                <a:latin typeface="Avenir"/>
-              </a:rPr>
-              <a:t>● </a:t>
-            </a:r>
-            <a:r>
-              <a:rPr lang="es-AR" sz="2000" b="1" i="0" dirty="0">
-                <a:solidFill>
-                  <a:schemeClr val="accent6">
-                    <a:lumMod val="75000"/>
-                  </a:schemeClr>
-                </a:solidFill>
-                <a:effectLst/>
-                <a:latin typeface="Avenir"/>
-              </a:rPr>
-              <a:t>Testeo y </a:t>
-            </a:r>
-            <a:r>
-              <a:rPr lang="es-AR" sz="2000" b="1" i="0" dirty="0" err="1">
-                <a:solidFill>
-                  <a:schemeClr val="accent6">
-                    <a:lumMod val="75000"/>
-                  </a:schemeClr>
-                </a:solidFill>
-                <a:effectLst/>
-                <a:latin typeface="Avenir"/>
-              </a:rPr>
-              <a:t>Debuggeo</a:t>
-            </a:r>
-            <a:r>
-              <a:rPr lang="es-AR" sz="2000" b="1" i="0" dirty="0">
-                <a:solidFill>
-                  <a:schemeClr val="accent6">
-                    <a:lumMod val="75000"/>
-                  </a:schemeClr>
-                </a:solidFill>
-                <a:effectLst/>
-                <a:latin typeface="Avenir"/>
-              </a:rPr>
-              <a:t> de programas: Diseño de experimentos. Manejos de excepciones. Control de flujos.</a:t>
+              <a:t>Python para el análisis de datos: Archivos de entrada/salida. Cómputo de estadísticos. </a:t>
             </a:r>
           </a:p>
           <a:p>
@@ -54337,7 +54174,7 @@
             </a:pPr>
             <a:r>
               <a:rPr lang="es-ES" dirty="0"/>
-              <a:t>Plan de Estudios – Programa</a:t>
+              <a:t>Plan de Estudios – Python</a:t>
             </a:r>
             <a:endParaRPr dirty="0"/>
           </a:p>
@@ -54814,7 +54651,7 @@
             </a:pPr>
             <a:r>
               <a:rPr lang="es-ES" dirty="0"/>
-              <a:t>Plan de Estudios – Programa</a:t>
+              <a:t>Plan de Estudios – Python</a:t>
             </a:r>
             <a:endParaRPr dirty="0"/>
           </a:p>
@@ -54944,7 +54781,7 @@
         <p:spPr>
           <a:xfrm>
             <a:off x="539496" y="1495840"/>
-            <a:ext cx="11652504" cy="4401205"/>
+            <a:ext cx="11228832" cy="4093428"/>
           </a:xfrm>
           <a:prstGeom prst="rect">
             <a:avLst/>
@@ -55176,39 +55013,7 @@
                 </a:solidFill>
                 <a:latin typeface="Avenir"/>
               </a:rPr>
-              <a:t>Es un entorno de cuaderno basado en HTML para Python. Proporciona un entorno basado en celdas con gran interactividad,</a:t>
-            </a:r>
-          </a:p>
-          <a:p>
-            <a:pPr>
-              <a:buNone/>
-            </a:pPr>
-            <a:r>
-              <a:rPr lang="es-AR" sz="2000" b="1" dirty="0">
-                <a:solidFill>
-                  <a:schemeClr val="accent6">
-                    <a:lumMod val="75000"/>
-                  </a:schemeClr>
-                </a:solidFill>
-                <a:latin typeface="Avenir"/>
-              </a:rPr>
-              <a:t>donde los cálculos se pueden organizar y documentar de forma estructurada. En nuestro curso vamos a utilizar este tipo de</a:t>
-            </a:r>
-          </a:p>
-          <a:p>
-            <a:pPr>
-              <a:buNone/>
-            </a:pPr>
-            <a:r>
-              <a:rPr lang="es-AR" sz="2000" b="1" dirty="0">
-                <a:solidFill>
-                  <a:schemeClr val="accent6">
-                    <a:lumMod val="75000"/>
-                  </a:schemeClr>
-                </a:solidFill>
-                <a:latin typeface="Avenir"/>
-              </a:rPr>
-              <a:t>entorno, en particular Google </a:t>
+              <a:t>Es un entorno de cuaderno basado en HTML para Python. Proporciona un entorno basado en celdas con gran interactividad, donde los cálculos se pueden organizar y documentar de forma estructurada. En nuestro curso vamos a utilizar este tipo de entorno, en particular Google </a:t>
             </a:r>
             <a:r>
               <a:rPr lang="es-AR" sz="2000" b="1" dirty="0" err="1">
@@ -55472,8 +55277,8 @@
         </p:nvSpPr>
         <p:spPr>
           <a:xfrm>
-            <a:off x="833175" y="1441180"/>
-            <a:ext cx="6094476" cy="1323439"/>
+            <a:off x="833174" y="1413748"/>
+            <a:ext cx="7012033" cy="1015663"/>
           </a:xfrm>
           <a:prstGeom prst="rect">
             <a:avLst/>

</xml_diff>